<commit_message>
Finalize deck QA and MiniMax framing
</commit_message>
<xml_diff>
--- a/Moltbook.pptx
+++ b/Moltbook.pptx
@@ -1047,7 +1047,8 @@
             <a:r>
               <a:rPr lang="en-US" dirty="0"/>
               <a:t>This chart is source-anchored. The prior repo version used synthetic time series.
-The MiniMax-vs-Opus case survives only as an audit note, not as a strong on-stage claim.</a:t>
+MiniMax M2.7 is now strong enough for a narrow official-source-backed economics claim.
+The safe line is that the price gap is clearer than the quality gap.</a:t>
             </a:r>
             <a:endParaRPr lang="en-US" dirty="0"/>
           </a:p>
@@ -1135,7 +1136,8 @@
           <a:p>
             <a:r>
               <a:rPr lang="en-US" dirty="0"/>
-              <a:t>This is the explicit red-team slide that was missing in the earlier repo.</a:t>
+              <a:t>This slide restores MiniMax to the deck, but only in its safe official-source-backed form.
+The old ~19x cheaper / ~6% worse framing should stay dead.</a:t>
             </a:r>
             <a:endParaRPr lang="en-US" dirty="0"/>
           </a:p>
@@ -2208,7 +2210,34 @@
       </p:sp>
       <p:sp>
         <p:nvSpPr>
-          <p:cNvPr id="7" name="Text 5"/>
+          <p:cNvPr id="7" name="Shape 5"/>
+          <p:cNvSpPr/>
+          <p:nvPr/>
+        </p:nvSpPr>
+        <p:spPr>
+          <a:xfrm>
+            <a:off x="658368" y="1234440"/>
+            <a:ext cx="10972800" cy="914400"/>
+          </a:xfrm>
+          <a:prstGeom prst="roundRect">
+            <a:avLst>
+              <a:gd name="adj" fmla="val 8000"/>
+            </a:avLst>
+          </a:prstGeom>
+          <a:solidFill>
+            <a:srgbClr val="FBF8F2"/>
+          </a:solidFill>
+          <a:ln w="12700">
+            <a:solidFill>
+              <a:srgbClr val="D6D3D1"/>
+            </a:solidFill>
+            <a:prstDash val="solid"/>
+          </a:ln>
+        </p:spPr>
+      </p:sp>
+      <p:sp>
+        <p:nvSpPr>
+          <p:cNvPr id="8" name="Text 6"/>
           <p:cNvSpPr/>
           <p:nvPr/>
         </p:nvSpPr>
@@ -2249,7 +2278,34 @@
       </p:sp>
       <p:sp>
         <p:nvSpPr>
-          <p:cNvPr id="8" name="Text 6"/>
+          <p:cNvPr id="9" name="Shape 7"/>
+          <p:cNvSpPr/>
+          <p:nvPr/>
+        </p:nvSpPr>
+        <p:spPr>
+          <a:xfrm>
+            <a:off x="658368" y="2057400"/>
+            <a:ext cx="10972800" cy="2148840"/>
+          </a:xfrm>
+          <a:prstGeom prst="roundRect">
+            <a:avLst>
+              <a:gd name="adj" fmla="val 3404"/>
+            </a:avLst>
+          </a:prstGeom>
+          <a:solidFill>
+            <a:srgbClr val="FBF8F2"/>
+          </a:solidFill>
+          <a:ln w="12700">
+            <a:solidFill>
+              <a:srgbClr val="D6D3D1"/>
+            </a:solidFill>
+            <a:prstDash val="solid"/>
+          </a:ln>
+        </p:spPr>
+      </p:sp>
+      <p:sp>
+        <p:nvSpPr>
+          <p:cNvPr id="10" name="Text 8"/>
           <p:cNvSpPr/>
           <p:nvPr/>
         </p:nvSpPr>
@@ -2347,7 +2403,34 @@
       </p:sp>
       <p:sp>
         <p:nvSpPr>
-          <p:cNvPr id="9" name="Text 7"/>
+          <p:cNvPr id="11" name="Shape 9"/>
+          <p:cNvSpPr/>
+          <p:nvPr/>
+        </p:nvSpPr>
+        <p:spPr>
+          <a:xfrm>
+            <a:off x="658368" y="4892040"/>
+            <a:ext cx="10972800" cy="1097280"/>
+          </a:xfrm>
+          <a:prstGeom prst="roundRect">
+            <a:avLst>
+              <a:gd name="adj" fmla="val 6667"/>
+            </a:avLst>
+          </a:prstGeom>
+          <a:solidFill>
+            <a:srgbClr val="FBF8F2"/>
+          </a:solidFill>
+          <a:ln w="12700">
+            <a:solidFill>
+              <a:srgbClr val="D6D3D1"/>
+            </a:solidFill>
+            <a:prstDash val="solid"/>
+          </a:ln>
+        </p:spPr>
+      </p:sp>
+      <p:sp>
+        <p:nvSpPr>
+          <p:cNvPr id="12" name="Text 10"/>
           <p:cNvSpPr/>
           <p:nvPr/>
         </p:nvSpPr>
@@ -2386,7 +2469,7 @@
       </p:sp>
       <p:sp>
         <p:nvSpPr>
-          <p:cNvPr id="10" name="Text 8"/>
+          <p:cNvPr id="13" name="Text 11"/>
           <p:cNvSpPr/>
           <p:nvPr/>
         </p:nvSpPr>
@@ -3373,7 +3456,7 @@
                 <a:ea typeface="Aptos Display" pitchFamily="34" charset="-122"/>
                 <a:cs typeface="Aptos Display" pitchFamily="34" charset="-120"/>
               </a:rPr>
-              <a:t>The cost story is real, but the exact social-cycle number is a scenario, not a measurement</a:t>
+              <a:t>The cost story is real, but the headline number is a scenario, not a measurement</a:t>
             </a:r>
             <a:endParaRPr lang="en-US" sz="2400" dirty="0"/>
           </a:p>
@@ -4202,7 +4285,7 @@
                 <a:ea typeface="Aptos Display" pitchFamily="34" charset="-122"/>
                 <a:cs typeface="Aptos Display" pitchFamily="34" charset="-120"/>
               </a:rPr>
-              <a:t>The strongest defensible trend claims are about cost, compute, and broad capability context</a:t>
+              <a:t>What the trend data cleanly supports</a:t>
             </a:r>
             <a:endParaRPr lang="en-US" sz="2400" dirty="0"/>
           </a:p>
@@ -4264,7 +4347,7 @@
                 <a:ea typeface="Aptos" pitchFamily="34" charset="-122"/>
                 <a:cs typeface="Aptos" pitchFamily="34" charset="-120"/>
               </a:rPr>
-              <a:t>Sources: Stanford HAI AI Index 2025 summary and Epoch AI trend snapshot, accessed 2026-03-23.</a:t>
+              <a:t>Source-backed metrics; MiniMax and Opus numbers are official vendor pages, not one neutral matched eval sheet.</a:t>
             </a:r>
             <a:endParaRPr lang="en-US" sz="800" dirty="0"/>
           </a:p>
@@ -4287,13 +4370,81 @@
         <p:spPr>
           <a:xfrm>
             <a:off x="566928" y="1234440"/>
-            <a:ext cx="10972800" cy="5166360"/>
+            <a:ext cx="10972800" cy="4754880"/>
           </a:xfrm>
           <a:prstGeom prst="rect">
             <a:avLst/>
           </a:prstGeom>
         </p:spPr>
       </p:pic>
+      <p:sp>
+        <p:nvSpPr>
+          <p:cNvPr id="8" name="Shape 5"/>
+          <p:cNvSpPr/>
+          <p:nvPr/>
+        </p:nvSpPr>
+        <p:spPr>
+          <a:xfrm>
+            <a:off x="777240" y="5577840"/>
+            <a:ext cx="10972800" cy="530352"/>
+          </a:xfrm>
+          <a:prstGeom prst="roundRect">
+            <a:avLst>
+              <a:gd name="adj" fmla="val 13793"/>
+            </a:avLst>
+          </a:prstGeom>
+          <a:solidFill>
+            <a:srgbClr val="FBF8F2"/>
+          </a:solidFill>
+          <a:ln w="12700">
+            <a:solidFill>
+              <a:srgbClr val="D6D3D1"/>
+            </a:solidFill>
+            <a:prstDash val="solid"/>
+          </a:ln>
+        </p:spPr>
+      </p:sp>
+      <p:sp>
+        <p:nvSpPr>
+          <p:cNvPr id="9" name="Text 6"/>
+          <p:cNvSpPr/>
+          <p:nvPr/>
+        </p:nvSpPr>
+        <p:spPr>
+          <a:xfrm>
+            <a:off x="914400" y="5742432"/>
+            <a:ext cx="10607040" cy="164592"/>
+          </a:xfrm>
+          <a:prstGeom prst="rect">
+            <a:avLst/>
+          </a:prstGeom>
+          <a:noFill/>
+          <a:ln/>
+        </p:spPr>
+        <p:txBody>
+          <a:bodyPr wrap="square" lIns="0" tIns="0" rIns="0" bIns="0" rtlCol="0" anchor="ctr">
+            <a:normAutofit/>
+          </a:bodyPr>
+          <a:lstStyle/>
+          <a:p>
+            <a:pPr indent="0" marL="0">
+              <a:buNone/>
+            </a:pPr>
+            <a:r>
+              <a:rPr lang="en-US" sz="900" dirty="0">
+                <a:solidFill>
+                  <a:srgbClr val="5C6773"/>
+                </a:solidFill>
+                <a:latin typeface="Aptos" pitchFamily="34" charset="0"/>
+                <a:ea typeface="Aptos" pitchFamily="34" charset="-122"/>
+                <a:cs typeface="Aptos" pitchFamily="34" charset="-120"/>
+              </a:rPr>
+              <a:t>Method note: source-backed metrics + official vendor snapshots; useful for direction, not a neutral matched leaderboard.</a:t>
+            </a:r>
+            <a:endParaRPr lang="en-US" sz="900" dirty="0"/>
+          </a:p>
+        </p:txBody>
+      </p:sp>
     </p:spTree>
   </p:cSld>
   <p:clrMapOvr>
@@ -4425,7 +4576,7 @@
                 <a:ea typeface="Aptos Display" pitchFamily="34" charset="-122"/>
                 <a:cs typeface="Aptos Display" pitchFamily="34" charset="-120"/>
               </a:rPr>
-              <a:t>Read curves carefully: not every upward line is an exponential law</a:t>
+              <a:t>Use the MiniMax comparison, but keep it on a short analytical leash</a:t>
             </a:r>
             <a:endParaRPr lang="en-US" sz="2400" dirty="0"/>
           </a:p>
@@ -4487,7 +4638,7 @@
                 <a:ea typeface="Aptos" pitchFamily="34" charset="-122"/>
                 <a:cs typeface="Aptos" pitchFamily="34" charset="-120"/>
               </a:rPr>
-              <a:t>Sources: Epoch ECI methodology and the repo's own red-team review.</a:t>
+              <a:t>Official MiniMax and Anthropic pages make the economics claim clean; the benchmark claim still needs caveats.</a:t>
             </a:r>
             <a:endParaRPr lang="en-US" sz="800" dirty="0"/>
           </a:p>
@@ -4555,7 +4706,7 @@
                 <a:ea typeface="Aptos" pitchFamily="34" charset="-122"/>
                 <a:cs typeface="Aptos" pitchFamily="34" charset="-120"/>
               </a:rPr>
-              <a:t>Safer language</a:t>
+              <a:t>What is now fair to say</a:t>
             </a:r>
             <a:endParaRPr lang="en-US" sz="1600" dirty="0"/>
           </a:p>
@@ -4578,7 +4729,7 @@
                 <a:ea typeface="Aptos" pitchFamily="34" charset="-122"/>
                 <a:cs typeface="Aptos" pitchFamily="34" charset="-120"/>
               </a:rPr>
-              <a:t>- Inference cost decline has been extremely fast.</a:t>
+              <a:t>- M2.7 is officially priced at $0.30 / $1.20 per 1M tokens.</a:t>
             </a:r>
             <a:endParaRPr lang="en-US" sz="1600" dirty="0"/>
           </a:p>
@@ -4595,7 +4746,7 @@
                 <a:ea typeface="Aptos" pitchFamily="34" charset="-122"/>
                 <a:cs typeface="Aptos" pitchFamily="34" charset="-120"/>
               </a:rPr>
-              <a:t>- Compute and efficiency trends are compounding strongly.</a:t>
+              <a:t>- Opus 4.6 is officially priced at $5 / $25 per 1M tokens.</a:t>
             </a:r>
             <a:endParaRPr lang="en-US" sz="1600" dirty="0"/>
           </a:p>
@@ -4612,7 +4763,7 @@
                 <a:ea typeface="Aptos" pitchFamily="34" charset="-122"/>
                 <a:cs typeface="Aptos" pitchFamily="34" charset="-120"/>
               </a:rPr>
-              <a:t>- Individual bounded benchmarks can jump, then saturate.</a:t>
+              <a:t>- Official Terminal Bench values are 57.0% for M2.7 and 65.4% for Opus 4.6.</a:t>
             </a:r>
             <a:endParaRPr lang="en-US" sz="1600" dirty="0"/>
           </a:p>
@@ -4629,7 +4780,7 @@
                 <a:ea typeface="Aptos" pitchFamily="34" charset="-122"/>
                 <a:cs typeface="Aptos" pitchFamily="34" charset="-120"/>
               </a:rPr>
-              <a:t>- ECI exists precisely because single benchmarks stop being informative over longer windows.</a:t>
+              <a:t>- Safe summary: much cheaper and still competitive on some agentic coding tasks.</a:t>
             </a:r>
             <a:endParaRPr lang="en-US" sz="1600" dirty="0"/>
           </a:p>
@@ -4697,7 +4848,7 @@
                 <a:ea typeface="Aptos" pitchFamily="34" charset="-122"/>
                 <a:cs typeface="Aptos" pitchFamily="34" charset="-120"/>
               </a:rPr>
-              <a:t>What was removed from the old deck</a:t>
+              <a:t>What still needs caution</a:t>
             </a:r>
             <a:endParaRPr lang="en-US" sz="1600" dirty="0"/>
           </a:p>
@@ -4720,7 +4871,7 @@
                 <a:ea typeface="Aptos" pitchFamily="34" charset="-122"/>
                 <a:cs typeface="Aptos" pitchFamily="34" charset="-120"/>
               </a:rPr>
-              <a:t>- 'Only ~6% worse' for MiniMax vs Opus.</a:t>
+              <a:t>- Do not say 'basically equal to Opus 4.6'.</a:t>
             </a:r>
             <a:endParaRPr lang="en-US" sz="1600" dirty="0"/>
           </a:p>
@@ -4737,7 +4888,7 @@
                 <a:ea typeface="Aptos" pitchFamily="34" charset="-122"/>
                 <a:cs typeface="Aptos" pitchFamily="34" charset="-120"/>
               </a:rPr>
-              <a:t>- Any implication that one sourced endpoint justifies a full empirical-looking curve.</a:t>
+              <a:t>- MiniMax's MMClaw note references Sonnet 4.6, not Opus 4.6.</a:t>
             </a:r>
             <a:endParaRPr lang="en-US" sz="1600" dirty="0"/>
           </a:p>
@@ -4754,7 +4905,24 @@
                 <a:ea typeface="Aptos" pitchFamily="34" charset="-122"/>
                 <a:cs typeface="Aptos" pitchFamily="34" charset="-120"/>
               </a:rPr>
-              <a:t>- Any use of screenshots as substitutes for the underlying citation.</a:t>
+              <a:t>- Vendor pages are not the same thing as one independent matched benchmark sheet.</a:t>
+            </a:r>
+            <a:endParaRPr lang="en-US" sz="1600" dirty="0"/>
+          </a:p>
+          <a:p>
+            <a:pPr indent="0" marL="0">
+              <a:buNone/>
+            </a:pPr>
+            <a:r>
+              <a:rPr lang="en-US" sz="1600" dirty="0">
+                <a:solidFill>
+                  <a:srgbClr val="17212B"/>
+                </a:solidFill>
+                <a:latin typeface="Aptos" pitchFamily="34" charset="0"/>
+                <a:ea typeface="Aptos" pitchFamily="34" charset="-122"/>
+                <a:cs typeface="Aptos" pitchFamily="34" charset="-120"/>
+              </a:rPr>
+              <a:t>- The clean on-stage line is: the price gap is clearer than the quality gap.</a:t>
             </a:r>
             <a:endParaRPr lang="en-US" sz="1600" dirty="0"/>
           </a:p>
@@ -4795,7 +4963,7 @@
                 <a:ea typeface="Aptos" pitchFamily="34" charset="-122"/>
                 <a:cs typeface="Aptos" pitchFamily="34" charset="-120"/>
               </a:rPr>
-              <a:t>The talk gets stronger when it says less, but says it more carefully.</a:t>
+              <a:t>If the wording feels punchier than the evidence, narrow the wording instead of defending the punch.</a:t>
             </a:r>
             <a:endParaRPr lang="en-US" sz="1800" dirty="0"/>
           </a:p>
@@ -4932,7 +5100,7 @@
                 <a:ea typeface="Aptos Display" pitchFamily="34" charset="-122"/>
                 <a:cs typeface="Aptos Display" pitchFamily="34" charset="-120"/>
               </a:rPr>
-              <a:t>The forecast model is useful as a scenario discipline, not as a prophecy</a:t>
+              <a:t>Forecasts: useful scenario discipline, not prophecy</a:t>
             </a:r>
             <a:endParaRPr lang="en-US" sz="2400" dirty="0"/>
           </a:p>
@@ -4994,7 +5162,7 @@
                 <a:ea typeface="Aptos" pitchFamily="34" charset="-122"/>
                 <a:cs typeface="Aptos" pitchFamily="34" charset="-120"/>
               </a:rPr>
-              <a:t>Inputs live in data/forecast_scenarios.json. All outputs are reproducible from uv.</a:t>
+              <a:t>Scenario outputs from explicit assumptions; not a deterministic forecast.</a:t>
             </a:r>
             <a:endParaRPr lang="en-US" sz="800" dirty="0"/>
           </a:p>
@@ -5017,13 +5185,81 @@
         <p:spPr>
           <a:xfrm>
             <a:off x="566928" y="1234440"/>
-            <a:ext cx="10972800" cy="5166360"/>
+            <a:ext cx="10972800" cy="4754880"/>
           </a:xfrm>
           <a:prstGeom prst="rect">
             <a:avLst/>
           </a:prstGeom>
         </p:spPr>
       </p:pic>
+      <p:sp>
+        <p:nvSpPr>
+          <p:cNvPr id="8" name="Shape 5"/>
+          <p:cNvSpPr/>
+          <p:nvPr/>
+        </p:nvSpPr>
+        <p:spPr>
+          <a:xfrm>
+            <a:off x="777240" y="5577840"/>
+            <a:ext cx="10972800" cy="530352"/>
+          </a:xfrm>
+          <a:prstGeom prst="roundRect">
+            <a:avLst>
+              <a:gd name="adj" fmla="val 13793"/>
+            </a:avLst>
+          </a:prstGeom>
+          <a:solidFill>
+            <a:srgbClr val="FBF8F2"/>
+          </a:solidFill>
+          <a:ln w="12700">
+            <a:solidFill>
+              <a:srgbClr val="D6D3D1"/>
+            </a:solidFill>
+            <a:prstDash val="solid"/>
+          </a:ln>
+        </p:spPr>
+      </p:sp>
+      <p:sp>
+        <p:nvSpPr>
+          <p:cNvPr id="9" name="Text 6"/>
+          <p:cNvSpPr/>
+          <p:nvPr/>
+        </p:nvSpPr>
+        <p:spPr>
+          <a:xfrm>
+            <a:off x="914400" y="5742432"/>
+            <a:ext cx="10607040" cy="164592"/>
+          </a:xfrm>
+          <a:prstGeom prst="rect">
+            <a:avLst/>
+          </a:prstGeom>
+          <a:noFill/>
+          <a:ln/>
+        </p:spPr>
+        <p:txBody>
+          <a:bodyPr wrap="square" lIns="0" tIns="0" rIns="0" bIns="0" rtlCol="0" anchor="ctr">
+            <a:normAutofit/>
+          </a:bodyPr>
+          <a:lstStyle/>
+          <a:p>
+            <a:pPr indent="0" marL="0">
+              <a:buNone/>
+            </a:pPr>
+            <a:r>
+              <a:rPr lang="en-US" sz="900" dirty="0">
+                <a:solidFill>
+                  <a:srgbClr val="5C6773"/>
+                </a:solidFill>
+                <a:latin typeface="Aptos" pitchFamily="34" charset="0"/>
+                <a:ea typeface="Aptos" pitchFamily="34" charset="-122"/>
+                <a:cs typeface="Aptos" pitchFamily="34" charset="-120"/>
+              </a:rPr>
+              <a:t>Barrier model + explicit scenario inputs + floor constraints. Treat this as a structured uncertainty map, not a date promise.</a:t>
+            </a:r>
+            <a:endParaRPr lang="en-US" sz="900" dirty="0"/>
+          </a:p>
+        </p:txBody>
+      </p:sp>
     </p:spTree>
   </p:cSld>
   <p:clrMapOvr>

</xml_diff>